<commit_message>
Update presentation files for final thesis submission
</commit_message>
<xml_diff>
--- a/thesis/final/Hairfall_Thesis_Presentation.pptx
+++ b/thesis/final/Hairfall_Thesis_Presentation.pptx
@@ -453,13 +453,13 @@
           </c:spPr>
           <c:invertIfNegative val="0"/>
           <c:dLbls>
-            <c:numFmt formatCode="0.0" sourceLinked="0"/>
+            <c:numFmt formatCode="#,##0" sourceLinked="0"/>
             <c:txPr>
               <a:bodyPr/>
               <a:lstStyle/>
               <a:p>
                 <a:pPr>
-                  <a:defRPr b="0" i="0" strike="noStrike" sz="1000" u="none">
+                  <a:defRPr b="0" i="0" strike="noStrike" sz="1200" u="none">
                     <a:solidFill>
                       <a:srgbClr val="000000"/>
                     </a:solidFill>
@@ -468,9 +468,8 @@
                 </a:pPr>
               </a:p>
             </c:txPr>
-            <c:dLblPos val="t"/>
             <c:showLegendKey val="0"/>
-            <c:showVal val="1"/>
+            <c:showVal val="0"/>
             <c:showCatName val="0"/>
             <c:showSerName val="0"/>
             <c:showPercent val="0"/>
@@ -568,13 +567,13 @@
           </c:spPr>
           <c:invertIfNegative val="0"/>
           <c:dLbls>
-            <c:numFmt formatCode="0.0" sourceLinked="0"/>
+            <c:numFmt formatCode="#,##0" sourceLinked="0"/>
             <c:txPr>
               <a:bodyPr/>
               <a:lstStyle/>
               <a:p>
                 <a:pPr>
-                  <a:defRPr b="0" i="0" strike="noStrike" sz="1000" u="none">
+                  <a:defRPr b="0" i="0" strike="noStrike" sz="1200" u="none">
                     <a:solidFill>
                       <a:srgbClr val="000000"/>
                     </a:solidFill>
@@ -583,9 +582,8 @@
                 </a:pPr>
               </a:p>
             </c:txPr>
-            <c:dLblPos val="t"/>
             <c:showLegendKey val="0"/>
-            <c:showVal val="1"/>
+            <c:showVal val="0"/>
             <c:showCatName val="0"/>
             <c:showSerName val="0"/>
             <c:showPercent val="0"/>
@@ -683,13 +681,13 @@
           </c:spPr>
           <c:invertIfNegative val="0"/>
           <c:dLbls>
-            <c:numFmt formatCode="0.0" sourceLinked="0"/>
+            <c:numFmt formatCode="#,##0" sourceLinked="0"/>
             <c:txPr>
               <a:bodyPr/>
               <a:lstStyle/>
               <a:p>
                 <a:pPr>
-                  <a:defRPr b="0" i="0" strike="noStrike" sz="1000" u="none">
+                  <a:defRPr b="0" i="0" strike="noStrike" sz="1200" u="none">
                     <a:solidFill>
                       <a:srgbClr val="000000"/>
                     </a:solidFill>
@@ -698,9 +696,8 @@
                 </a:pPr>
               </a:p>
             </c:txPr>
-            <c:dLblPos val="t"/>
             <c:showLegendKey val="0"/>
-            <c:showVal val="1"/>
+            <c:showVal val="0"/>
             <c:showCatName val="0"/>
             <c:showSerName val="0"/>
             <c:showPercent val="0"/>
@@ -770,13 +767,13 @@
           <c:smooth val="0"/>
         </c:ser>
         <c:dLbls>
-          <c:numFmt formatCode="0.0" sourceLinked="0"/>
+          <c:numFmt formatCode="#,##0" sourceLinked="0"/>
           <c:txPr>
             <a:bodyPr/>
             <a:lstStyle/>
             <a:p>
               <a:pPr>
-                <a:defRPr b="0" i="0" strike="noStrike" sz="1000" u="none">
+                <a:defRPr b="0" i="0" strike="noStrike" sz="1200" u="none">
                   <a:solidFill>
                     <a:srgbClr val="000000"/>
                   </a:solidFill>
@@ -785,9 +782,8 @@
               </a:pPr>
             </a:p>
           </c:txPr>
-          <c:dLblPos val="t"/>
           <c:showLegendKey val="0"/>
-          <c:showVal val="1"/>
+          <c:showVal val="0"/>
           <c:showCatName val="0"/>
           <c:showSerName val="0"/>
           <c:showPercent val="0"/>
@@ -6465,12 +6461,12 @@
         </p:nvSpPr>
         <p:spPr>
           <a:xfrm>
-            <a:off x="548640" y="1691640"/>
-            <a:ext cx="2286000" cy="2103120"/>
+            <a:off x="548640" y="1828800"/>
+            <a:ext cx="2286000" cy="2286000"/>
           </a:xfrm>
           <a:prstGeom prst="roundRect">
             <a:avLst>
-              <a:gd name="adj" fmla="val 3478"/>
+              <a:gd name="adj" fmla="val 3200"/>
             </a:avLst>
           </a:prstGeom>
           <a:solidFill>
@@ -6492,7 +6488,7 @@
         </p:nvSpPr>
         <p:spPr>
           <a:xfrm>
-            <a:off x="731520" y="1874520"/>
+            <a:off x="731520" y="2057400"/>
             <a:ext cx="1920240" cy="731520"/>
           </a:xfrm>
           <a:prstGeom prst="rect">
@@ -6531,7 +6527,7 @@
         </p:nvSpPr>
         <p:spPr>
           <a:xfrm>
-            <a:off x="731520" y="2606040"/>
+            <a:off x="731520" y="2834640"/>
             <a:ext cx="1920240" cy="320040"/>
           </a:xfrm>
           <a:prstGeom prst="rect">
@@ -6570,7 +6566,7 @@
         </p:nvSpPr>
         <p:spPr>
           <a:xfrm>
-            <a:off x="731520" y="3063240"/>
+            <a:off x="731520" y="3337560"/>
             <a:ext cx="1920240" cy="457200"/>
           </a:xfrm>
           <a:prstGeom prst="rect">
@@ -6609,12 +6605,12 @@
         </p:nvSpPr>
         <p:spPr>
           <a:xfrm>
-            <a:off x="3063240" y="1691640"/>
-            <a:ext cx="2286000" cy="2103120"/>
+            <a:off x="3063240" y="1828800"/>
+            <a:ext cx="2286000" cy="2286000"/>
           </a:xfrm>
           <a:prstGeom prst="roundRect">
             <a:avLst>
-              <a:gd name="adj" fmla="val 3478"/>
+              <a:gd name="adj" fmla="val 3200"/>
             </a:avLst>
           </a:prstGeom>
           <a:solidFill>
@@ -6636,7 +6632,7 @@
         </p:nvSpPr>
         <p:spPr>
           <a:xfrm>
-            <a:off x="3246120" y="1874520"/>
+            <a:off x="3246120" y="2057400"/>
             <a:ext cx="1920240" cy="731520"/>
           </a:xfrm>
           <a:prstGeom prst="rect">
@@ -6675,7 +6671,7 @@
         </p:nvSpPr>
         <p:spPr>
           <a:xfrm>
-            <a:off x="3246120" y="2606040"/>
+            <a:off x="3246120" y="2834640"/>
             <a:ext cx="1920240" cy="320040"/>
           </a:xfrm>
           <a:prstGeom prst="rect">
@@ -6714,7 +6710,7 @@
         </p:nvSpPr>
         <p:spPr>
           <a:xfrm>
-            <a:off x="3246120" y="3063240"/>
+            <a:off x="3246120" y="3337560"/>
             <a:ext cx="1920240" cy="457200"/>
           </a:xfrm>
           <a:prstGeom prst="rect">
@@ -6753,12 +6749,12 @@
         </p:nvSpPr>
         <p:spPr>
           <a:xfrm>
-            <a:off x="5577840" y="1691640"/>
-            <a:ext cx="2286000" cy="2103120"/>
+            <a:off x="5577840" y="1828800"/>
+            <a:ext cx="2286000" cy="2286000"/>
           </a:xfrm>
           <a:prstGeom prst="roundRect">
             <a:avLst>
-              <a:gd name="adj" fmla="val 3478"/>
+              <a:gd name="adj" fmla="val 3200"/>
             </a:avLst>
           </a:prstGeom>
           <a:solidFill>
@@ -6780,7 +6776,7 @@
         </p:nvSpPr>
         <p:spPr>
           <a:xfrm>
-            <a:off x="5760720" y="1874520"/>
+            <a:off x="5760720" y="2057400"/>
             <a:ext cx="1920240" cy="731520"/>
           </a:xfrm>
           <a:prstGeom prst="rect">
@@ -6819,7 +6815,7 @@
         </p:nvSpPr>
         <p:spPr>
           <a:xfrm>
-            <a:off x="5760720" y="2606040"/>
+            <a:off x="5760720" y="2834640"/>
             <a:ext cx="1920240" cy="320040"/>
           </a:xfrm>
           <a:prstGeom prst="rect">
@@ -6847,7 +6843,7 @@
         </p:nvSpPr>
         <p:spPr>
           <a:xfrm>
-            <a:off x="5760720" y="3063240"/>
+            <a:off x="5760720" y="3337560"/>
             <a:ext cx="1920240" cy="457200"/>
           </a:xfrm>
           <a:prstGeom prst="rect">
@@ -6886,7 +6882,7 @@
         </p:nvSpPr>
         <p:spPr>
           <a:xfrm>
-            <a:off x="548640" y="4023360"/>
+            <a:off x="548640" y="4389120"/>
             <a:ext cx="7315200" cy="411480"/>
           </a:xfrm>
           <a:prstGeom prst="rect">
@@ -6925,7 +6921,7 @@
         </p:nvSpPr>
         <p:spPr>
           <a:xfrm>
-            <a:off x="8412480" y="1691640"/>
+            <a:off x="8412480" y="1828800"/>
             <a:ext cx="3291840" cy="365760"/>
           </a:xfrm>
           <a:prstGeom prst="rect">
@@ -6964,7 +6960,7 @@
         </p:nvSpPr>
         <p:spPr>
           <a:xfrm>
-            <a:off x="8412480" y="2194560"/>
+            <a:off x="8412480" y="2377440"/>
             <a:ext cx="502920" cy="502920"/>
           </a:xfrm>
           <a:prstGeom prst="ellipse">
@@ -6997,7 +6993,7 @@
         </p:blipFill>
         <p:spPr>
           <a:xfrm>
-            <a:off x="8543239" y="2325319"/>
+            <a:off x="8543239" y="2508199"/>
             <a:ext cx="241402" cy="241402"/>
           </a:xfrm>
           <a:prstGeom prst="rect">
@@ -7013,8 +7009,8 @@
         </p:nvSpPr>
         <p:spPr>
           <a:xfrm>
-            <a:off x="9098280" y="2148840"/>
-            <a:ext cx="2606040" cy="914400"/>
+            <a:off x="9098280" y="2331720"/>
+            <a:ext cx="2606040" cy="1005840"/>
           </a:xfrm>
           <a:prstGeom prst="rect">
             <a:avLst/>
@@ -7030,7 +7026,7 @@
               <a:buNone/>
             </a:pPr>
             <a:r>
-              <a:rPr lang="en-US" sz="1400" dirty="0">
+              <a:rPr lang="en-US" sz="1500" dirty="0">
                 <a:solidFill>
                   <a:srgbClr val="1B1F2A"/>
                 </a:solidFill>
@@ -7040,7 +7036,7 @@
               </a:rPr>
               <a:t>SHAP Permutation → numba error; used KernelExplainer</a:t>
             </a:r>
-            <a:endParaRPr lang="en-US" sz="1400" dirty="0"/>
+            <a:endParaRPr lang="en-US" sz="1500" dirty="0"/>
           </a:p>
         </p:txBody>
       </p:sp>
@@ -7052,7 +7048,7 @@
         </p:nvSpPr>
         <p:spPr>
           <a:xfrm>
-            <a:off x="8412480" y="3291840"/>
+            <a:off x="8412480" y="3611880"/>
             <a:ext cx="502920" cy="502920"/>
           </a:xfrm>
           <a:prstGeom prst="ellipse">
@@ -7085,7 +7081,7 @@
         </p:blipFill>
         <p:spPr>
           <a:xfrm>
-            <a:off x="8543239" y="3422599"/>
+            <a:off x="8543239" y="3742639"/>
             <a:ext cx="241402" cy="241402"/>
           </a:xfrm>
           <a:prstGeom prst="rect">
@@ -7101,8 +7097,8 @@
         </p:nvSpPr>
         <p:spPr>
           <a:xfrm>
-            <a:off x="9098280" y="3246120"/>
-            <a:ext cx="2606040" cy="914400"/>
+            <a:off x="9098280" y="3566160"/>
+            <a:ext cx="2606040" cy="1005840"/>
           </a:xfrm>
           <a:prstGeom prst="rect">
             <a:avLst/>
@@ -7118,7 +7114,7 @@
               <a:buNone/>
             </a:pPr>
             <a:r>
-              <a:rPr lang="en-US" sz="1400" dirty="0">
+              <a:rPr lang="en-US" sz="1500" dirty="0">
                 <a:solidFill>
                   <a:srgbClr val="1B1F2A"/>
                 </a:solidFill>
@@ -7128,7 +7124,7 @@
               </a:rPr>
               <a:t>TabFM crashed on 1-row input; padded to 2 rows</a:t>
             </a:r>
-            <a:endParaRPr lang="en-US" sz="1400" dirty="0"/>
+            <a:endParaRPr lang="en-US" sz="1500" dirty="0"/>
           </a:p>
         </p:txBody>
       </p:sp>
@@ -7140,7 +7136,7 @@
         </p:nvSpPr>
         <p:spPr>
           <a:xfrm>
-            <a:off x="8412480" y="4389120"/>
+            <a:off x="8412480" y="4846320"/>
             <a:ext cx="502920" cy="502920"/>
           </a:xfrm>
           <a:prstGeom prst="ellipse">
@@ -7173,7 +7169,7 @@
         </p:blipFill>
         <p:spPr>
           <a:xfrm>
-            <a:off x="8543239" y="4519879"/>
+            <a:off x="8543239" y="4977079"/>
             <a:ext cx="241402" cy="241402"/>
           </a:xfrm>
           <a:prstGeom prst="rect">
@@ -7189,8 +7185,8 @@
         </p:nvSpPr>
         <p:spPr>
           <a:xfrm>
-            <a:off x="9098280" y="4343400"/>
-            <a:ext cx="2606040" cy="914400"/>
+            <a:off x="9098280" y="4800600"/>
+            <a:ext cx="2606040" cy="1005840"/>
           </a:xfrm>
           <a:prstGeom prst="rect">
             <a:avLst/>
@@ -7206,7 +7202,7 @@
               <a:buNone/>
             </a:pPr>
             <a:r>
-              <a:rPr lang="en-US" sz="1400" dirty="0">
+              <a:rPr lang="en-US" sz="1500" dirty="0">
                 <a:solidFill>
                   <a:srgbClr val="1B1F2A"/>
                 </a:solidFill>
@@ -7216,7 +7212,7 @@
               </a:rPr>
               <a:t>TabPFN checkpoint load; patched torch.load</a:t>
             </a:r>
-            <a:endParaRPr lang="en-US" sz="1400" dirty="0"/>
+            <a:endParaRPr lang="en-US" sz="1500" dirty="0"/>
           </a:p>
         </p:txBody>
       </p:sp>
@@ -7228,7 +7224,7 @@
         </p:nvSpPr>
         <p:spPr>
           <a:xfrm>
-            <a:off x="548640" y="4709160"/>
+            <a:off x="548640" y="4983480"/>
             <a:ext cx="7315200" cy="1188720"/>
           </a:xfrm>
           <a:prstGeom prst="roundRect">
@@ -7255,7 +7251,7 @@
         </p:nvSpPr>
         <p:spPr>
           <a:xfrm>
-            <a:off x="822960" y="4709160"/>
+            <a:off x="822960" y="4983480"/>
             <a:ext cx="6766560" cy="1188720"/>
           </a:xfrm>
           <a:prstGeom prst="rect">
@@ -7272,7 +7268,7 @@
               <a:buNone/>
             </a:pPr>
             <a:r>
-              <a:rPr lang="en-US" sz="1500" dirty="0">
+              <a:rPr lang="en-US" sz="1600" dirty="0">
                 <a:solidFill>
                   <a:srgbClr val="5B6170"/>
                 </a:solidFill>
@@ -7282,7 +7278,7 @@
               </a:rPr>
               <a:t>Choice depends on data size and number of predictions: CatBoost is cheap to run once trained; foundation models need no training but pay at every prediction.</a:t>
             </a:r>
-            <a:endParaRPr lang="en-US" sz="1500" dirty="0"/>
+            <a:endParaRPr lang="en-US" sz="1600" dirty="0"/>
           </a:p>
         </p:txBody>
       </p:sp>
@@ -8187,12 +8183,12 @@
         </p:nvSpPr>
         <p:spPr>
           <a:xfrm>
-            <a:off x="548640" y="1371600"/>
-            <a:ext cx="5394960" cy="4572000"/>
+            <a:off x="548640" y="1463040"/>
+            <a:ext cx="5394960" cy="4206240"/>
           </a:xfrm>
           <a:prstGeom prst="roundRect">
             <a:avLst>
-              <a:gd name="adj" fmla="val 1600"/>
+              <a:gd name="adj" fmla="val 1739"/>
             </a:avLst>
           </a:prstGeom>
           <a:solidFill>
@@ -8214,7 +8210,7 @@
         </p:nvSpPr>
         <p:spPr>
           <a:xfrm>
-            <a:off x="822960" y="1600200"/>
+            <a:off x="822960" y="1691640"/>
             <a:ext cx="548640" cy="548640"/>
           </a:xfrm>
           <a:prstGeom prst="ellipse">
@@ -8247,7 +8243,7 @@
         </p:blipFill>
         <p:spPr>
           <a:xfrm>
-            <a:off x="965606" y="1742846"/>
+            <a:off x="965606" y="1834286"/>
             <a:ext cx="263347" cy="263347"/>
           </a:xfrm>
           <a:prstGeom prst="rect">
@@ -8263,7 +8259,7 @@
         </p:nvSpPr>
         <p:spPr>
           <a:xfrm>
-            <a:off x="1554480" y="1645920"/>
+            <a:off x="1554480" y="1737360"/>
             <a:ext cx="4114800" cy="457200"/>
           </a:xfrm>
           <a:prstGeom prst="rect">
@@ -8302,8 +8298,8 @@
         </p:nvSpPr>
         <p:spPr>
           <a:xfrm>
-            <a:off x="868680" y="2377440"/>
-            <a:ext cx="4846320" cy="3383280"/>
+            <a:off x="868680" y="2468880"/>
+            <a:ext cx="4846320" cy="3017520"/>
           </a:xfrm>
           <a:prstGeom prst="rect">
             <a:avLst/>
@@ -8323,7 +8319,7 @@
               <a:buChar char="•"/>
             </a:pPr>
             <a:r>
-              <a:rPr lang="en-US" sz="1600" dirty="0">
+              <a:rPr lang="en-US" sz="1800" dirty="0">
                 <a:solidFill>
                   <a:srgbClr val="1B1F2A"/>
                 </a:solidFill>
@@ -8333,7 +8329,7 @@
               </a:rPr>
               <a:t>Constructed dataset — not clinical validation</a:t>
             </a:r>
-            <a:endParaRPr lang="en-US" sz="1600" dirty="0"/>
+            <a:endParaRPr lang="en-US" sz="1800" dirty="0"/>
           </a:p>
           <a:p>
             <a:pPr marL="203200" indent="-203200">
@@ -8344,7 +8340,7 @@
               <a:buChar char="•"/>
             </a:pPr>
             <a:r>
-              <a:rPr lang="en-US" sz="1600" dirty="0">
+              <a:rPr lang="en-US" sz="1800" dirty="0">
                 <a:solidFill>
                   <a:srgbClr val="1B1F2A"/>
                 </a:solidFill>
@@ -8354,7 +8350,7 @@
               </a:rPr>
               <a:t>TabFM used 500 rows, not full data</a:t>
             </a:r>
-            <a:endParaRPr lang="en-US" sz="1600" dirty="0"/>
+            <a:endParaRPr lang="en-US" sz="1800" dirty="0"/>
           </a:p>
           <a:p>
             <a:pPr marL="203200" indent="-203200">
@@ -8365,7 +8361,7 @@
               <a:buChar char="•"/>
             </a:pPr>
             <a:r>
-              <a:rPr lang="en-US" sz="1600" dirty="0">
+              <a:rPr lang="en-US" sz="1800" dirty="0">
                 <a:solidFill>
                   <a:srgbClr val="1B1F2A"/>
                 </a:solidFill>
@@ -8375,7 +8371,7 @@
               </a:rPr>
               <a:t>SHAP for foundation models on 20–30 records</a:t>
             </a:r>
-            <a:endParaRPr lang="en-US" sz="1600" dirty="0"/>
+            <a:endParaRPr lang="en-US" sz="1800" dirty="0"/>
           </a:p>
           <a:p>
             <a:pPr marL="203200" indent="-203200">
@@ -8386,7 +8382,7 @@
               <a:buChar char="•"/>
             </a:pPr>
             <a:r>
-              <a:rPr lang="en-US" sz="1600" dirty="0">
+              <a:rPr lang="en-US" sz="1800" dirty="0">
                 <a:solidFill>
                   <a:srgbClr val="1B1F2A"/>
                 </a:solidFill>
@@ -8396,7 +8392,7 @@
               </a:rPr>
               <a:t>One split, one seed; early stopping used test set</a:t>
             </a:r>
-            <a:endParaRPr lang="en-US" sz="1600" dirty="0"/>
+            <a:endParaRPr lang="en-US" sz="1800" dirty="0"/>
           </a:p>
         </p:txBody>
       </p:sp>
@@ -8408,12 +8404,12 @@
         </p:nvSpPr>
         <p:spPr>
           <a:xfrm>
-            <a:off x="6245352" y="1371600"/>
-            <a:ext cx="5394960" cy="4572000"/>
+            <a:off x="6245352" y="1463040"/>
+            <a:ext cx="5394960" cy="4206240"/>
           </a:xfrm>
           <a:prstGeom prst="roundRect">
             <a:avLst>
-              <a:gd name="adj" fmla="val 1600"/>
+              <a:gd name="adj" fmla="val 1739"/>
             </a:avLst>
           </a:prstGeom>
           <a:solidFill>
@@ -8435,7 +8431,7 @@
         </p:nvSpPr>
         <p:spPr>
           <a:xfrm>
-            <a:off x="6519672" y="1600200"/>
+            <a:off x="6519672" y="1691640"/>
             <a:ext cx="548640" cy="548640"/>
           </a:xfrm>
           <a:prstGeom prst="ellipse">
@@ -8468,7 +8464,7 @@
         </p:blipFill>
         <p:spPr>
           <a:xfrm>
-            <a:off x="6662318" y="1742846"/>
+            <a:off x="6662318" y="1834286"/>
             <a:ext cx="263347" cy="263347"/>
           </a:xfrm>
           <a:prstGeom prst="rect">
@@ -8484,7 +8480,7 @@
         </p:nvSpPr>
         <p:spPr>
           <a:xfrm>
-            <a:off x="7251192" y="1645920"/>
+            <a:off x="7251192" y="1737360"/>
             <a:ext cx="4114800" cy="457200"/>
           </a:xfrm>
           <a:prstGeom prst="rect">
@@ -8523,8 +8519,8 @@
         </p:nvSpPr>
         <p:spPr>
           <a:xfrm>
-            <a:off x="6565392" y="2377440"/>
-            <a:ext cx="4846320" cy="3383280"/>
+            <a:off x="6565392" y="2468880"/>
+            <a:ext cx="4846320" cy="3017520"/>
           </a:xfrm>
           <a:prstGeom prst="rect">
             <a:avLst/>
@@ -8544,7 +8540,7 @@
               <a:buChar char="•"/>
             </a:pPr>
             <a:r>
-              <a:rPr lang="en-US" sz="1600" dirty="0">
+              <a:rPr lang="en-US" sz="1800" dirty="0">
                 <a:solidFill>
                   <a:srgbClr val="FFFFFF"/>
                 </a:solidFill>
@@ -8554,7 +8550,7 @@
               </a:rPr>
               <a:t>Validate on real clinical data</a:t>
             </a:r>
-            <a:endParaRPr lang="en-US" sz="1600" dirty="0"/>
+            <a:endParaRPr lang="en-US" sz="1800" dirty="0"/>
           </a:p>
           <a:p>
             <a:pPr marL="203200" indent="-203200">
@@ -8565,7 +8561,7 @@
               <a:buChar char="•"/>
             </a:pPr>
             <a:r>
-              <a:rPr lang="en-US" sz="1600" dirty="0">
+              <a:rPr lang="en-US" sz="1800" dirty="0">
                 <a:solidFill>
                   <a:srgbClr val="FFFFFF"/>
                 </a:solidFill>
@@ -8575,7 +8571,7 @@
               </a:rPr>
               <a:t>Full-context TabFM, several seeds and splits</a:t>
             </a:r>
-            <a:endParaRPr lang="en-US" sz="1600" dirty="0"/>
+            <a:endParaRPr lang="en-US" sz="1800" dirty="0"/>
           </a:p>
           <a:p>
             <a:pPr marL="203200" indent="-203200">
@@ -8586,7 +8582,7 @@
               <a:buChar char="•"/>
             </a:pPr>
             <a:r>
-              <a:rPr lang="en-US" sz="1600" dirty="0">
+              <a:rPr lang="en-US" sz="1800" dirty="0">
                 <a:solidFill>
                   <a:srgbClr val="FFFFFF"/>
                 </a:solidFill>
@@ -8596,7 +8592,7 @@
               </a:rPr>
               <a:t>Larger SHAP samples</a:t>
             </a:r>
-            <a:endParaRPr lang="en-US" sz="1600" dirty="0"/>
+            <a:endParaRPr lang="en-US" sz="1800" dirty="0"/>
           </a:p>
           <a:p>
             <a:pPr marL="203200" indent="-203200">
@@ -8607,7 +8603,7 @@
               <a:buChar char="•"/>
             </a:pPr>
             <a:r>
-              <a:rPr lang="en-US" sz="1600" dirty="0">
+              <a:rPr lang="en-US" sz="1800" dirty="0">
                 <a:solidFill>
                   <a:srgbClr val="FFFFFF"/>
                 </a:solidFill>
@@ -8617,7 +8613,7 @@
               </a:rPr>
               <a:t>Ordinal models for the Moderate tier</a:t>
             </a:r>
-            <a:endParaRPr lang="en-US" sz="1600" dirty="0"/>
+            <a:endParaRPr lang="en-US" sz="1800" dirty="0"/>
           </a:p>
           <a:p>
             <a:pPr marL="203200" indent="-203200">
@@ -8628,7 +8624,7 @@
               <a:buChar char="•"/>
             </a:pPr>
             <a:r>
-              <a:rPr lang="en-US" sz="1600" dirty="0">
+              <a:rPr lang="en-US" sz="1800" dirty="0">
                 <a:solidFill>
                   <a:srgbClr val="FFFFFF"/>
                 </a:solidFill>
@@ -8638,7 +8634,7 @@
               </a:rPr>
               <a:t>Ensembles and lightweight distilled models</a:t>
             </a:r>
-            <a:endParaRPr lang="en-US" sz="1600" dirty="0"/>
+            <a:endParaRPr lang="en-US" sz="1800" dirty="0"/>
           </a:p>
         </p:txBody>
       </p:sp>
@@ -10856,11 +10852,11 @@
         <p:spPr>
           <a:xfrm>
             <a:off x="548640" y="1691640"/>
-            <a:ext cx="3474720" cy="4023360"/>
+            <a:ext cx="3474720" cy="3246120"/>
           </a:xfrm>
           <a:prstGeom prst="roundRect">
             <a:avLst>
-              <a:gd name="adj" fmla="val 2105"/>
+              <a:gd name="adj" fmla="val 2254"/>
             </a:avLst>
           </a:prstGeom>
           <a:solidFill>
@@ -10931,7 +10927,7 @@
         </p:nvSpPr>
         <p:spPr>
           <a:xfrm>
-            <a:off x="868680" y="2926080"/>
+            <a:off x="868680" y="2880360"/>
             <a:ext cx="2834640" cy="731520"/>
           </a:xfrm>
           <a:prstGeom prst="rect">
@@ -10970,8 +10966,8 @@
         </p:nvSpPr>
         <p:spPr>
           <a:xfrm>
-            <a:off x="868680" y="3703320"/>
-            <a:ext cx="2834640" cy="1737360"/>
+            <a:off x="868680" y="3611880"/>
+            <a:ext cx="2834640" cy="1188720"/>
           </a:xfrm>
           <a:prstGeom prst="rect">
             <a:avLst/>
@@ -11010,11 +11006,11 @@
         <p:spPr>
           <a:xfrm>
             <a:off x="4297680" y="1691640"/>
-            <a:ext cx="3474720" cy="4023360"/>
+            <a:ext cx="3474720" cy="3246120"/>
           </a:xfrm>
           <a:prstGeom prst="roundRect">
             <a:avLst>
-              <a:gd name="adj" fmla="val 2105"/>
+              <a:gd name="adj" fmla="val 2254"/>
             </a:avLst>
           </a:prstGeom>
           <a:solidFill>
@@ -11085,7 +11081,7 @@
         </p:nvSpPr>
         <p:spPr>
           <a:xfrm>
-            <a:off x="4617720" y="2926080"/>
+            <a:off x="4617720" y="2880360"/>
             <a:ext cx="2834640" cy="731520"/>
           </a:xfrm>
           <a:prstGeom prst="rect">
@@ -11124,8 +11120,8 @@
         </p:nvSpPr>
         <p:spPr>
           <a:xfrm>
-            <a:off x="4617720" y="3703320"/>
-            <a:ext cx="2834640" cy="1737360"/>
+            <a:off x="4617720" y="3611880"/>
+            <a:ext cx="2834640" cy="1188720"/>
           </a:xfrm>
           <a:prstGeom prst="rect">
             <a:avLst/>
@@ -11164,11 +11160,11 @@
         <p:spPr>
           <a:xfrm>
             <a:off x="8046720" y="1691640"/>
-            <a:ext cx="3474720" cy="4023360"/>
+            <a:ext cx="3474720" cy="3246120"/>
           </a:xfrm>
           <a:prstGeom prst="roundRect">
             <a:avLst>
-              <a:gd name="adj" fmla="val 2105"/>
+              <a:gd name="adj" fmla="val 2254"/>
             </a:avLst>
           </a:prstGeom>
           <a:solidFill>
@@ -11239,7 +11235,7 @@
         </p:nvSpPr>
         <p:spPr>
           <a:xfrm>
-            <a:off x="8366760" y="2926080"/>
+            <a:off x="8366760" y="2880360"/>
             <a:ext cx="2834640" cy="731520"/>
           </a:xfrm>
           <a:prstGeom prst="rect">
@@ -11278,8 +11274,8 @@
         </p:nvSpPr>
         <p:spPr>
           <a:xfrm>
-            <a:off x="8366760" y="3703320"/>
-            <a:ext cx="2834640" cy="1737360"/>
+            <a:off x="8366760" y="3611880"/>
+            <a:ext cx="2834640" cy="1188720"/>
           </a:xfrm>
           <a:prstGeom prst="rect">
             <a:avLst/>
@@ -11306,6 +11302,86 @@
               <a:t>Accurate models are hard to explain — clinicians cannot check the reason.</a:t>
             </a:r>
             <a:endParaRPr lang="en-US" sz="1500" dirty="0"/>
+          </a:p>
+        </p:txBody>
+      </p:sp>
+      <p:sp>
+        <p:nvSpPr>
+          <p:cNvPr id="19" name="Shape 14"/>
+          <p:cNvSpPr/>
+          <p:nvPr/>
+        </p:nvSpPr>
+        <p:spPr>
+          <a:xfrm>
+            <a:off x="548640" y="5212080"/>
+            <a:ext cx="11094415" cy="868680"/>
+          </a:xfrm>
+          <a:prstGeom prst="roundRect">
+            <a:avLst>
+              <a:gd name="adj" fmla="val 8421"/>
+            </a:avLst>
+          </a:prstGeom>
+          <a:solidFill>
+            <a:srgbClr val="1B1F2A"/>
+          </a:solidFill>
+          <a:ln w="12700">
+            <a:solidFill>
+              <a:srgbClr val="1B1F2A"/>
+            </a:solidFill>
+            <a:prstDash val="solid"/>
+          </a:ln>
+        </p:spPr>
+      </p:sp>
+      <p:sp>
+        <p:nvSpPr>
+          <p:cNvPr id="20" name="Text 15"/>
+          <p:cNvSpPr txBox="1"/>
+          <p:nvPr/>
+        </p:nvSpPr>
+        <p:spPr>
+          <a:xfrm>
+            <a:off x="868680" y="5212080"/>
+            <a:ext cx="10454335" cy="868680"/>
+          </a:xfrm>
+          <a:prstGeom prst="rect">
+            <a:avLst/>
+          </a:prstGeom>
+          <a:noFill/>
+          <a:ln/>
+        </p:spPr>
+        <p:txBody>
+          <a:bodyPr wrap="square" lIns="0" tIns="0" rIns="0" bIns="0" rtlCol="0" anchor="ctr"/>
+          <a:lstStyle/>
+          <a:p>
+            <a:pPr indent="0" marL="0">
+              <a:buNone/>
+            </a:pPr>
+            <a:r>
+              <a:rPr lang="en-US" sz="1700" b="1" dirty="0">
+                <a:solidFill>
+                  <a:srgbClr val="F2A0AB"/>
+                </a:solidFill>
+                <a:latin typeface="Calibri" pitchFamily="34" charset="0"/>
+                <a:ea typeface="Calibri" pitchFamily="34" charset="-122"/>
+                <a:cs typeface="Calibri" pitchFamily="34" charset="-120"/>
+              </a:rPr>
+              <a:t>This study:  </a:t>
+            </a:r>
+            <a:pPr indent="0" marL="0">
+              <a:buNone/>
+            </a:pPr>
+            <a:r>
+              <a:rPr lang="en-US" sz="1700" dirty="0">
+                <a:solidFill>
+                  <a:srgbClr val="FFFFFF"/>
+                </a:solidFill>
+                <a:latin typeface="Calibri" pitchFamily="34" charset="0"/>
+                <a:ea typeface="Calibri" pitchFamily="34" charset="-122"/>
+                <a:cs typeface="Calibri" pitchFamily="34" charset="-120"/>
+              </a:rPr>
+              <a:t>a fair benchmark of CatBoost, TabPFN and TabFM on the same data — with SHAP for every model.</a:t>
+            </a:r>
+            <a:endParaRPr lang="en-US" sz="1700" dirty="0"/>
           </a:p>
         </p:txBody>
       </p:sp>
@@ -13289,8 +13365,8 @@
         </p:nvSpPr>
         <p:spPr>
           <a:xfrm>
-            <a:off x="548640" y="2103120"/>
-            <a:ext cx="1691640" cy="2926080"/>
+            <a:off x="548640" y="1874520"/>
+            <a:ext cx="1691640" cy="3200400"/>
           </a:xfrm>
           <a:prstGeom prst="roundRect">
             <a:avLst>
@@ -13316,7 +13392,7 @@
         </p:nvSpPr>
         <p:spPr>
           <a:xfrm>
-            <a:off x="1028700" y="2423160"/>
+            <a:off x="1028700" y="2194560"/>
             <a:ext cx="731520" cy="731520"/>
           </a:xfrm>
           <a:prstGeom prst="ellipse">
@@ -13349,7 +13425,7 @@
         </p:blipFill>
         <p:spPr>
           <a:xfrm>
-            <a:off x="1218895" y="2613355"/>
+            <a:off x="1218895" y="2384755"/>
             <a:ext cx="351130" cy="351130"/>
           </a:xfrm>
           <a:prstGeom prst="rect">
@@ -13365,7 +13441,7 @@
         </p:nvSpPr>
         <p:spPr>
           <a:xfrm>
-            <a:off x="640080" y="3337560"/>
+            <a:off x="640080" y="3200400"/>
             <a:ext cx="1508760" cy="411480"/>
           </a:xfrm>
           <a:prstGeom prst="rect">
@@ -13382,7 +13458,7 @@
               <a:buNone/>
             </a:pPr>
             <a:r>
-              <a:rPr lang="en-US" sz="1800" b="1" dirty="0">
+              <a:rPr lang="en-US" sz="1900" b="1" dirty="0">
                 <a:solidFill>
                   <a:srgbClr val="1B1F2A"/>
                 </a:solidFill>
@@ -13392,7 +13468,7 @@
               </a:rPr>
               <a:t>Data</a:t>
             </a:r>
-            <a:endParaRPr lang="en-US" sz="1800" dirty="0"/>
+            <a:endParaRPr lang="en-US" sz="1900" dirty="0"/>
           </a:p>
         </p:txBody>
       </p:sp>
@@ -13404,8 +13480,8 @@
         </p:nvSpPr>
         <p:spPr>
           <a:xfrm>
-            <a:off x="640080" y="3840480"/>
-            <a:ext cx="1508760" cy="1005840"/>
+            <a:off x="640080" y="3749040"/>
+            <a:ext cx="1508760" cy="1097280"/>
           </a:xfrm>
           <a:prstGeom prst="rect">
             <a:avLst/>
@@ -13421,7 +13497,7 @@
               <a:buNone/>
             </a:pPr>
             <a:r>
-              <a:rPr lang="en-US" sz="1350" dirty="0">
+              <a:rPr lang="en-US" sz="1500" dirty="0">
                 <a:solidFill>
                   <a:srgbClr val="5B6170"/>
                 </a:solidFill>
@@ -13431,14 +13507,14 @@
               </a:rPr>
               <a:t>21,606 records</a:t>
             </a:r>
-            <a:endParaRPr lang="en-US" sz="1350" dirty="0"/>
+            <a:endParaRPr lang="en-US" sz="1500" dirty="0"/>
           </a:p>
           <a:p>
             <a:pPr algn="ctr" indent="0" marL="0">
               <a:buNone/>
             </a:pPr>
             <a:r>
-              <a:rPr lang="en-US" sz="1350" dirty="0">
+              <a:rPr lang="en-US" sz="1500" dirty="0">
                 <a:solidFill>
                   <a:srgbClr val="5B6170"/>
                 </a:solidFill>
@@ -13448,7 +13524,7 @@
               </a:rPr>
               <a:t>20 features</a:t>
             </a:r>
-            <a:endParaRPr lang="en-US" sz="1350" dirty="0"/>
+            <a:endParaRPr lang="en-US" sz="1500" dirty="0"/>
           </a:p>
         </p:txBody>
       </p:sp>
@@ -13460,7 +13536,7 @@
         </p:nvSpPr>
         <p:spPr>
           <a:xfrm>
-            <a:off x="2240280" y="3200400"/>
+            <a:off x="2240280" y="2971800"/>
             <a:ext cx="188915" cy="548640"/>
           </a:xfrm>
           <a:prstGeom prst="rect">
@@ -13499,8 +13575,8 @@
         </p:nvSpPr>
         <p:spPr>
           <a:xfrm>
-            <a:off x="2429195" y="2103120"/>
-            <a:ext cx="1691640" cy="2926080"/>
+            <a:off x="2429195" y="1874520"/>
+            <a:ext cx="1691640" cy="3200400"/>
           </a:xfrm>
           <a:prstGeom prst="roundRect">
             <a:avLst>
@@ -13526,7 +13602,7 @@
         </p:nvSpPr>
         <p:spPr>
           <a:xfrm>
-            <a:off x="2909255" y="2423160"/>
+            <a:off x="2909255" y="2194560"/>
             <a:ext cx="731520" cy="731520"/>
           </a:xfrm>
           <a:prstGeom prst="ellipse">
@@ -13559,7 +13635,7 @@
         </p:blipFill>
         <p:spPr>
           <a:xfrm>
-            <a:off x="3099450" y="2613355"/>
+            <a:off x="3099450" y="2384755"/>
             <a:ext cx="351130" cy="351130"/>
           </a:xfrm>
           <a:prstGeom prst="rect">
@@ -13575,7 +13651,7 @@
         </p:nvSpPr>
         <p:spPr>
           <a:xfrm>
-            <a:off x="2520635" y="3337560"/>
+            <a:off x="2520635" y="3200400"/>
             <a:ext cx="1508760" cy="411480"/>
           </a:xfrm>
           <a:prstGeom prst="rect">
@@ -13592,7 +13668,7 @@
               <a:buNone/>
             </a:pPr>
             <a:r>
-              <a:rPr lang="en-US" sz="1800" b="1" dirty="0">
+              <a:rPr lang="en-US" sz="1900" b="1" dirty="0">
                 <a:solidFill>
                   <a:srgbClr val="1B1F2A"/>
                 </a:solidFill>
@@ -13602,7 +13678,7 @@
               </a:rPr>
               <a:t>Preprocess</a:t>
             </a:r>
-            <a:endParaRPr lang="en-US" sz="1800" dirty="0"/>
+            <a:endParaRPr lang="en-US" sz="1900" dirty="0"/>
           </a:p>
         </p:txBody>
       </p:sp>
@@ -13614,8 +13690,8 @@
         </p:nvSpPr>
         <p:spPr>
           <a:xfrm>
-            <a:off x="2520635" y="3840480"/>
-            <a:ext cx="1508760" cy="1005840"/>
+            <a:off x="2520635" y="3749040"/>
+            <a:ext cx="1508760" cy="1097280"/>
           </a:xfrm>
           <a:prstGeom prst="rect">
             <a:avLst/>
@@ -13631,7 +13707,7 @@
               <a:buNone/>
             </a:pPr>
             <a:r>
-              <a:rPr lang="en-US" sz="1350" dirty="0">
+              <a:rPr lang="en-US" sz="1500" dirty="0">
                 <a:solidFill>
                   <a:srgbClr val="5B6170"/>
                 </a:solidFill>
@@ -13641,14 +13717,14 @@
               </a:rPr>
               <a:t>drop IDs</a:t>
             </a:r>
-            <a:endParaRPr lang="en-US" sz="1350" dirty="0"/>
+            <a:endParaRPr lang="en-US" sz="1500" dirty="0"/>
           </a:p>
           <a:p>
             <a:pPr algn="ctr" indent="0" marL="0">
               <a:buNone/>
             </a:pPr>
             <a:r>
-              <a:rPr lang="en-US" sz="1350" dirty="0">
+              <a:rPr lang="en-US" sz="1500" dirty="0">
                 <a:solidFill>
                   <a:srgbClr val="5B6170"/>
                 </a:solidFill>
@@ -13658,7 +13734,7 @@
               </a:rPr>
               <a:t>encode gender</a:t>
             </a:r>
-            <a:endParaRPr lang="en-US" sz="1350" dirty="0"/>
+            <a:endParaRPr lang="en-US" sz="1500" dirty="0"/>
           </a:p>
         </p:txBody>
       </p:sp>
@@ -13670,7 +13746,7 @@
         </p:nvSpPr>
         <p:spPr>
           <a:xfrm>
-            <a:off x="4120835" y="3200400"/>
+            <a:off x="4120835" y="2971800"/>
             <a:ext cx="188915" cy="548640"/>
           </a:xfrm>
           <a:prstGeom prst="rect">
@@ -13709,8 +13785,8 @@
         </p:nvSpPr>
         <p:spPr>
           <a:xfrm>
-            <a:off x="4309750" y="2103120"/>
-            <a:ext cx="1691640" cy="2926080"/>
+            <a:off x="4309750" y="1874520"/>
+            <a:ext cx="1691640" cy="3200400"/>
           </a:xfrm>
           <a:prstGeom prst="roundRect">
             <a:avLst>
@@ -13736,7 +13812,7 @@
         </p:nvSpPr>
         <p:spPr>
           <a:xfrm>
-            <a:off x="4789810" y="2423160"/>
+            <a:off x="4789810" y="2194560"/>
             <a:ext cx="731520" cy="731520"/>
           </a:xfrm>
           <a:prstGeom prst="ellipse">
@@ -13769,7 +13845,7 @@
         </p:blipFill>
         <p:spPr>
           <a:xfrm>
-            <a:off x="4980005" y="2613355"/>
+            <a:off x="4980005" y="2384755"/>
             <a:ext cx="351130" cy="351130"/>
           </a:xfrm>
           <a:prstGeom prst="rect">
@@ -13785,7 +13861,7 @@
         </p:nvSpPr>
         <p:spPr>
           <a:xfrm>
-            <a:off x="4401190" y="3337560"/>
+            <a:off x="4401190" y="3200400"/>
             <a:ext cx="1508760" cy="411480"/>
           </a:xfrm>
           <a:prstGeom prst="rect">
@@ -13802,7 +13878,7 @@
               <a:buNone/>
             </a:pPr>
             <a:r>
-              <a:rPr lang="en-US" sz="1800" b="1" dirty="0">
+              <a:rPr lang="en-US" sz="1900" b="1" dirty="0">
                 <a:solidFill>
                   <a:srgbClr val="1B1F2A"/>
                 </a:solidFill>
@@ -13812,7 +13888,7 @@
               </a:rPr>
               <a:t>Split</a:t>
             </a:r>
-            <a:endParaRPr lang="en-US" sz="1800" dirty="0"/>
+            <a:endParaRPr lang="en-US" sz="1900" dirty="0"/>
           </a:p>
         </p:txBody>
       </p:sp>
@@ -13824,8 +13900,8 @@
         </p:nvSpPr>
         <p:spPr>
           <a:xfrm>
-            <a:off x="4401190" y="3840480"/>
-            <a:ext cx="1508760" cy="1005840"/>
+            <a:off x="4401190" y="3749040"/>
+            <a:ext cx="1508760" cy="1097280"/>
           </a:xfrm>
           <a:prstGeom prst="rect">
             <a:avLst/>
@@ -13841,7 +13917,7 @@
               <a:buNone/>
             </a:pPr>
             <a:r>
-              <a:rPr lang="en-US" sz="1350" dirty="0">
+              <a:rPr lang="en-US" sz="1500" dirty="0">
                 <a:solidFill>
                   <a:srgbClr val="5B6170"/>
                 </a:solidFill>
@@ -13851,14 +13927,14 @@
               </a:rPr>
               <a:t>80 / 20 stratified</a:t>
             </a:r>
-            <a:endParaRPr lang="en-US" sz="1350" dirty="0"/>
+            <a:endParaRPr lang="en-US" sz="1500" dirty="0"/>
           </a:p>
           <a:p>
             <a:pPr algn="ctr" indent="0" marL="0">
               <a:buNone/>
             </a:pPr>
             <a:r>
-              <a:rPr lang="en-US" sz="1350" dirty="0">
+              <a:rPr lang="en-US" sz="1500" dirty="0">
                 <a:solidFill>
                   <a:srgbClr val="5B6170"/>
                 </a:solidFill>
@@ -13868,7 +13944,7 @@
               </a:rPr>
               <a:t>seed 42</a:t>
             </a:r>
-            <a:endParaRPr lang="en-US" sz="1350" dirty="0"/>
+            <a:endParaRPr lang="en-US" sz="1500" dirty="0"/>
           </a:p>
         </p:txBody>
       </p:sp>
@@ -13880,7 +13956,7 @@
         </p:nvSpPr>
         <p:spPr>
           <a:xfrm>
-            <a:off x="6001390" y="3200400"/>
+            <a:off x="6001390" y="2971800"/>
             <a:ext cx="188915" cy="548640"/>
           </a:xfrm>
           <a:prstGeom prst="rect">
@@ -13919,8 +13995,8 @@
         </p:nvSpPr>
         <p:spPr>
           <a:xfrm>
-            <a:off x="6190305" y="2103120"/>
-            <a:ext cx="1691640" cy="2926080"/>
+            <a:off x="6190305" y="1874520"/>
+            <a:ext cx="1691640" cy="3200400"/>
           </a:xfrm>
           <a:prstGeom prst="roundRect">
             <a:avLst>
@@ -13946,7 +14022,7 @@
         </p:nvSpPr>
         <p:spPr>
           <a:xfrm>
-            <a:off x="6670365" y="2423160"/>
+            <a:off x="6670365" y="2194560"/>
             <a:ext cx="731520" cy="731520"/>
           </a:xfrm>
           <a:prstGeom prst="ellipse">
@@ -13979,7 +14055,7 @@
         </p:blipFill>
         <p:spPr>
           <a:xfrm>
-            <a:off x="6860560" y="2613355"/>
+            <a:off x="6860560" y="2384755"/>
             <a:ext cx="351130" cy="351130"/>
           </a:xfrm>
           <a:prstGeom prst="rect">
@@ -13995,7 +14071,7 @@
         </p:nvSpPr>
         <p:spPr>
           <a:xfrm>
-            <a:off x="6281745" y="3337560"/>
+            <a:off x="6281745" y="3200400"/>
             <a:ext cx="1508760" cy="411480"/>
           </a:xfrm>
           <a:prstGeom prst="rect">
@@ -14012,7 +14088,7 @@
               <a:buNone/>
             </a:pPr>
             <a:r>
-              <a:rPr lang="en-US" sz="1800" b="1" dirty="0">
+              <a:rPr lang="en-US" sz="1900" b="1" dirty="0">
                 <a:solidFill>
                   <a:srgbClr val="FFFFFF"/>
                 </a:solidFill>
@@ -14022,7 +14098,7 @@
               </a:rPr>
               <a:t>Models</a:t>
             </a:r>
-            <a:endParaRPr lang="en-US" sz="1800" dirty="0"/>
+            <a:endParaRPr lang="en-US" sz="1900" dirty="0"/>
           </a:p>
         </p:txBody>
       </p:sp>
@@ -14034,8 +14110,8 @@
         </p:nvSpPr>
         <p:spPr>
           <a:xfrm>
-            <a:off x="6281745" y="3840480"/>
-            <a:ext cx="1508760" cy="1005840"/>
+            <a:off x="6281745" y="3749040"/>
+            <a:ext cx="1508760" cy="1097280"/>
           </a:xfrm>
           <a:prstGeom prst="rect">
             <a:avLst/>
@@ -14051,7 +14127,7 @@
               <a:buNone/>
             </a:pPr>
             <a:r>
-              <a:rPr lang="en-US" sz="1350" dirty="0">
+              <a:rPr lang="en-US" sz="1500" dirty="0">
                 <a:solidFill>
                   <a:srgbClr val="D5D8DF"/>
                 </a:solidFill>
@@ -14061,14 +14137,14 @@
               </a:rPr>
               <a:t>CatBoost · TabPFN</a:t>
             </a:r>
-            <a:endParaRPr lang="en-US" sz="1350" dirty="0"/>
+            <a:endParaRPr lang="en-US" sz="1500" dirty="0"/>
           </a:p>
           <a:p>
             <a:pPr algn="ctr" indent="0" marL="0">
               <a:buNone/>
             </a:pPr>
             <a:r>
-              <a:rPr lang="en-US" sz="1350" dirty="0">
+              <a:rPr lang="en-US" sz="1500" dirty="0">
                 <a:solidFill>
                   <a:srgbClr val="D5D8DF"/>
                 </a:solidFill>
@@ -14078,7 +14154,7 @@
               </a:rPr>
               <a:t>· TabFM</a:t>
             </a:r>
-            <a:endParaRPr lang="en-US" sz="1350" dirty="0"/>
+            <a:endParaRPr lang="en-US" sz="1500" dirty="0"/>
           </a:p>
         </p:txBody>
       </p:sp>
@@ -14090,7 +14166,7 @@
         </p:nvSpPr>
         <p:spPr>
           <a:xfrm>
-            <a:off x="7881945" y="3200400"/>
+            <a:off x="7881945" y="2971800"/>
             <a:ext cx="188915" cy="548640"/>
           </a:xfrm>
           <a:prstGeom prst="rect">
@@ -14129,8 +14205,8 @@
         </p:nvSpPr>
         <p:spPr>
           <a:xfrm>
-            <a:off x="8070860" y="2103120"/>
-            <a:ext cx="1691640" cy="2926080"/>
+            <a:off x="8070860" y="1874520"/>
+            <a:ext cx="1691640" cy="3200400"/>
           </a:xfrm>
           <a:prstGeom prst="roundRect">
             <a:avLst>
@@ -14156,7 +14232,7 @@
         </p:nvSpPr>
         <p:spPr>
           <a:xfrm>
-            <a:off x="8550920" y="2423160"/>
+            <a:off x="8550920" y="2194560"/>
             <a:ext cx="731520" cy="731520"/>
           </a:xfrm>
           <a:prstGeom prst="ellipse">
@@ -14189,7 +14265,7 @@
         </p:blipFill>
         <p:spPr>
           <a:xfrm>
-            <a:off x="8741115" y="2613355"/>
+            <a:off x="8741115" y="2384755"/>
             <a:ext cx="351130" cy="351130"/>
           </a:xfrm>
           <a:prstGeom prst="rect">
@@ -14205,7 +14281,7 @@
         </p:nvSpPr>
         <p:spPr>
           <a:xfrm>
-            <a:off x="8162300" y="3337560"/>
+            <a:off x="8162300" y="3200400"/>
             <a:ext cx="1508760" cy="411480"/>
           </a:xfrm>
           <a:prstGeom prst="rect">
@@ -14222,7 +14298,7 @@
               <a:buNone/>
             </a:pPr>
             <a:r>
-              <a:rPr lang="en-US" sz="1800" b="1" dirty="0">
+              <a:rPr lang="en-US" sz="1900" b="1" dirty="0">
                 <a:solidFill>
                   <a:srgbClr val="1B1F2A"/>
                 </a:solidFill>
@@ -14232,7 +14308,7 @@
               </a:rPr>
               <a:t>Evaluate</a:t>
             </a:r>
-            <a:endParaRPr lang="en-US" sz="1800" dirty="0"/>
+            <a:endParaRPr lang="en-US" sz="1900" dirty="0"/>
           </a:p>
         </p:txBody>
       </p:sp>
@@ -14244,8 +14320,8 @@
         </p:nvSpPr>
         <p:spPr>
           <a:xfrm>
-            <a:off x="8162300" y="3840480"/>
-            <a:ext cx="1508760" cy="1005840"/>
+            <a:off x="8162300" y="3749040"/>
+            <a:ext cx="1508760" cy="1097280"/>
           </a:xfrm>
           <a:prstGeom prst="rect">
             <a:avLst/>
@@ -14261,7 +14337,7 @@
               <a:buNone/>
             </a:pPr>
             <a:r>
-              <a:rPr lang="en-US" sz="1350" dirty="0">
+              <a:rPr lang="en-US" sz="1500" dirty="0">
                 <a:solidFill>
                   <a:srgbClr val="5B6170"/>
                 </a:solidFill>
@@ -14271,14 +14347,14 @@
               </a:rPr>
               <a:t>metrics · McNemar</a:t>
             </a:r>
-            <a:endParaRPr lang="en-US" sz="1350" dirty="0"/>
+            <a:endParaRPr lang="en-US" sz="1500" dirty="0"/>
           </a:p>
           <a:p>
             <a:pPr algn="ctr" indent="0" marL="0">
               <a:buNone/>
             </a:pPr>
             <a:r>
-              <a:rPr lang="en-US" sz="1350" dirty="0">
+              <a:rPr lang="en-US" sz="1500" dirty="0">
                 <a:solidFill>
                   <a:srgbClr val="5B6170"/>
                 </a:solidFill>
@@ -14288,7 +14364,7 @@
               </a:rPr>
               <a:t>context sizes</a:t>
             </a:r>
-            <a:endParaRPr lang="en-US" sz="1350" dirty="0"/>
+            <a:endParaRPr lang="en-US" sz="1500" dirty="0"/>
           </a:p>
         </p:txBody>
       </p:sp>
@@ -14300,7 +14376,7 @@
         </p:nvSpPr>
         <p:spPr>
           <a:xfrm>
-            <a:off x="9762500" y="3200400"/>
+            <a:off x="9762500" y="2971800"/>
             <a:ext cx="188915" cy="548640"/>
           </a:xfrm>
           <a:prstGeom prst="rect">
@@ -14339,8 +14415,8 @@
         </p:nvSpPr>
         <p:spPr>
           <a:xfrm>
-            <a:off x="9951415" y="2103120"/>
-            <a:ext cx="1691640" cy="2926080"/>
+            <a:off x="9951415" y="1874520"/>
+            <a:ext cx="1691640" cy="3200400"/>
           </a:xfrm>
           <a:prstGeom prst="roundRect">
             <a:avLst>
@@ -14366,7 +14442,7 @@
         </p:nvSpPr>
         <p:spPr>
           <a:xfrm>
-            <a:off x="10431475" y="2423160"/>
+            <a:off x="10431475" y="2194560"/>
             <a:ext cx="731520" cy="731520"/>
           </a:xfrm>
           <a:prstGeom prst="ellipse">
@@ -14399,7 +14475,7 @@
         </p:blipFill>
         <p:spPr>
           <a:xfrm>
-            <a:off x="10621670" y="2613355"/>
+            <a:off x="10621670" y="2384755"/>
             <a:ext cx="351130" cy="351130"/>
           </a:xfrm>
           <a:prstGeom prst="rect">
@@ -14415,7 +14491,7 @@
         </p:nvSpPr>
         <p:spPr>
           <a:xfrm>
-            <a:off x="10042855" y="3337560"/>
+            <a:off x="10042855" y="3200400"/>
             <a:ext cx="1508760" cy="411480"/>
           </a:xfrm>
           <a:prstGeom prst="rect">
@@ -14432,7 +14508,7 @@
               <a:buNone/>
             </a:pPr>
             <a:r>
-              <a:rPr lang="en-US" sz="1800" b="1" dirty="0">
+              <a:rPr lang="en-US" sz="1900" b="1" dirty="0">
                 <a:solidFill>
                   <a:srgbClr val="1B1F2A"/>
                 </a:solidFill>
@@ -14442,7 +14518,7 @@
               </a:rPr>
               <a:t>Explain</a:t>
             </a:r>
-            <a:endParaRPr lang="en-US" sz="1800" dirty="0"/>
+            <a:endParaRPr lang="en-US" sz="1900" dirty="0"/>
           </a:p>
         </p:txBody>
       </p:sp>
@@ -14454,8 +14530,8 @@
         </p:nvSpPr>
         <p:spPr>
           <a:xfrm>
-            <a:off x="10042855" y="3840480"/>
-            <a:ext cx="1508760" cy="1005840"/>
+            <a:off x="10042855" y="3749040"/>
+            <a:ext cx="1508760" cy="1097280"/>
           </a:xfrm>
           <a:prstGeom prst="rect">
             <a:avLst/>
@@ -14471,7 +14547,7 @@
               <a:buNone/>
             </a:pPr>
             <a:r>
-              <a:rPr lang="en-US" sz="1350" dirty="0">
+              <a:rPr lang="en-US" sz="1500" dirty="0">
                 <a:solidFill>
                   <a:srgbClr val="5B6170"/>
                 </a:solidFill>
@@ -14481,14 +14557,14 @@
               </a:rPr>
               <a:t>SHAP</a:t>
             </a:r>
-            <a:endParaRPr lang="en-US" sz="1350" dirty="0"/>
+            <a:endParaRPr lang="en-US" sz="1500" dirty="0"/>
           </a:p>
           <a:p>
             <a:pPr algn="ctr" indent="0" marL="0">
               <a:buNone/>
             </a:pPr>
             <a:r>
-              <a:rPr lang="en-US" sz="1350" dirty="0">
+              <a:rPr lang="en-US" sz="1500" dirty="0">
                 <a:solidFill>
                   <a:srgbClr val="5B6170"/>
                 </a:solidFill>
@@ -14498,7 +14574,7 @@
               </a:rPr>
               <a:t>for all models</a:t>
             </a:r>
-            <a:endParaRPr lang="en-US" sz="1350" dirty="0"/>
+            <a:endParaRPr lang="en-US" sz="1500" dirty="0"/>
           </a:p>
         </p:txBody>
       </p:sp>
@@ -14527,7 +14603,7 @@
               <a:buNone/>
             </a:pPr>
             <a:r>
-              <a:rPr lang="en-US" sz="1300" dirty="0">
+              <a:rPr lang="en-US" sz="1400" dirty="0">
                 <a:solidFill>
                   <a:srgbClr val="5B6170"/>
                 </a:solidFill>
@@ -14537,7 +14613,7 @@
               </a:rPr>
               <a:t>Tools: Python · scikit-learn · catboost · tabpfn · tabfm · shap · statsmodels  |  Kaggle &amp; Google Colab, NVIDIA T4 GPU</a:t>
             </a:r>
-            <a:endParaRPr lang="en-US" sz="1300" dirty="0"/>
+            <a:endParaRPr lang="en-US" sz="1400" dirty="0"/>
           </a:p>
         </p:txBody>
       </p:sp>
@@ -15536,11 +15612,11 @@
         <p:spPr>
           <a:xfrm>
             <a:off x="548640" y="2834640"/>
-            <a:ext cx="3474720" cy="2926080"/>
+            <a:ext cx="3474720" cy="3017520"/>
           </a:xfrm>
           <a:prstGeom prst="roundRect">
             <a:avLst>
-              <a:gd name="adj" fmla="val 2500"/>
+              <a:gd name="adj" fmla="val 2424"/>
             </a:avLst>
           </a:prstGeom>
           <a:solidFill>
@@ -15562,8 +15638,8 @@
         </p:nvSpPr>
         <p:spPr>
           <a:xfrm>
-            <a:off x="822960" y="3063240"/>
-            <a:ext cx="2926080" cy="2560320"/>
+            <a:off x="822960" y="3108960"/>
+            <a:ext cx="2926080" cy="2651760"/>
           </a:xfrm>
           <a:prstGeom prst="rect">
             <a:avLst/>
@@ -15583,7 +15659,7 @@
               <a:buChar char="•"/>
             </a:pPr>
             <a:r>
-              <a:rPr lang="en-US" sz="1600" dirty="0">
+              <a:rPr lang="en-US" sz="1800" dirty="0">
                 <a:solidFill>
                   <a:srgbClr val="1B1F2A"/>
                 </a:solidFill>
@@ -15593,7 +15669,7 @@
               </a:rPr>
               <a:t>Grid search: depth × learning rate</a:t>
             </a:r>
-            <a:endParaRPr lang="en-US" sz="1600" dirty="0"/>
+            <a:endParaRPr lang="en-US" sz="1800" dirty="0"/>
           </a:p>
           <a:p>
             <a:pPr marL="203200" indent="-203200">
@@ -15604,7 +15680,7 @@
               <a:buChar char="•"/>
             </a:pPr>
             <a:r>
-              <a:rPr lang="en-US" sz="1600" dirty="0">
+              <a:rPr lang="en-US" sz="1800" dirty="0">
                 <a:solidFill>
                   <a:srgbClr val="1B1F2A"/>
                 </a:solidFill>
@@ -15614,7 +15690,7 @@
               </a:rPr>
               <a:t>5-fold stratified CV</a:t>
             </a:r>
-            <a:endParaRPr lang="en-US" sz="1600" dirty="0"/>
+            <a:endParaRPr lang="en-US" sz="1800" dirty="0"/>
           </a:p>
           <a:p>
             <a:pPr marL="203200" indent="-203200">
@@ -15625,7 +15701,7 @@
               <a:buChar char="•"/>
             </a:pPr>
             <a:r>
-              <a:rPr lang="en-US" sz="1600" dirty="0">
+              <a:rPr lang="en-US" sz="1800" dirty="0">
                 <a:solidFill>
                   <a:srgbClr val="1B1F2A"/>
                 </a:solidFill>
@@ -15635,7 +15711,7 @@
               </a:rPr>
               <a:t>Best: depth 4, lr 0.1</a:t>
             </a:r>
-            <a:endParaRPr lang="en-US" sz="1600" dirty="0"/>
+            <a:endParaRPr lang="en-US" sz="1800" dirty="0"/>
           </a:p>
           <a:p>
             <a:pPr marL="203200" indent="-203200">
@@ -15646,7 +15722,7 @@
               <a:buChar char="•"/>
             </a:pPr>
             <a:r>
-              <a:rPr lang="en-US" sz="1600" dirty="0">
+              <a:rPr lang="en-US" sz="1800" dirty="0">
                 <a:solidFill>
                   <a:srgbClr val="1B1F2A"/>
                 </a:solidFill>
@@ -15656,7 +15732,7 @@
               </a:rPr>
               <a:t>17,284 training rows</a:t>
             </a:r>
-            <a:endParaRPr lang="en-US" sz="1600" dirty="0"/>
+            <a:endParaRPr lang="en-US" sz="1800" dirty="0"/>
           </a:p>
         </p:txBody>
       </p:sp>
@@ -15774,11 +15850,11 @@
         <p:spPr>
           <a:xfrm>
             <a:off x="4297680" y="2834640"/>
-            <a:ext cx="3474720" cy="2926080"/>
+            <a:ext cx="3474720" cy="3017520"/>
           </a:xfrm>
           <a:prstGeom prst="roundRect">
             <a:avLst>
-              <a:gd name="adj" fmla="val 2500"/>
+              <a:gd name="adj" fmla="val 2424"/>
             </a:avLst>
           </a:prstGeom>
           <a:solidFill>
@@ -15800,8 +15876,8 @@
         </p:nvSpPr>
         <p:spPr>
           <a:xfrm>
-            <a:off x="4572000" y="3063240"/>
-            <a:ext cx="2926080" cy="2560320"/>
+            <a:off x="4572000" y="3108960"/>
+            <a:ext cx="2926080" cy="2651760"/>
           </a:xfrm>
           <a:prstGeom prst="rect">
             <a:avLst/>
@@ -15821,7 +15897,7 @@
               <a:buChar char="•"/>
             </a:pPr>
             <a:r>
-              <a:rPr lang="en-US" sz="1600" dirty="0">
+              <a:rPr lang="en-US" sz="1800" dirty="0">
                 <a:solidFill>
                   <a:srgbClr val="1B1F2A"/>
                 </a:solidFill>
@@ -15831,7 +15907,7 @@
               </a:rPr>
               <a:t>No training, no tuning</a:t>
             </a:r>
-            <a:endParaRPr lang="en-US" sz="1600" dirty="0"/>
+            <a:endParaRPr lang="en-US" sz="1800" dirty="0"/>
           </a:p>
           <a:p>
             <a:pPr marL="203200" indent="-203200">
@@ -15842,7 +15918,7 @@
               <a:buChar char="•"/>
             </a:pPr>
             <a:r>
-              <a:rPr lang="en-US" sz="1600" dirty="0">
+              <a:rPr lang="en-US" sz="1800" dirty="0">
                 <a:solidFill>
                   <a:srgbClr val="1B1F2A"/>
                 </a:solidFill>
@@ -15852,7 +15928,7 @@
               </a:rPr>
               <a:t>Training rows given as context</a:t>
             </a:r>
-            <a:endParaRPr lang="en-US" sz="1600" dirty="0"/>
+            <a:endParaRPr lang="en-US" sz="1800" dirty="0"/>
           </a:p>
           <a:p>
             <a:pPr marL="203200" indent="-203200">
@@ -15863,7 +15939,7 @@
               <a:buChar char="•"/>
             </a:pPr>
             <a:r>
-              <a:rPr lang="en-US" sz="1600" dirty="0">
+              <a:rPr lang="en-US" sz="1800" dirty="0">
                 <a:solidFill>
                   <a:srgbClr val="1B1F2A"/>
                 </a:solidFill>
@@ -15873,7 +15949,7 @@
               </a:rPr>
               <a:t>One forward pass</a:t>
             </a:r>
-            <a:endParaRPr lang="en-US" sz="1600" dirty="0"/>
+            <a:endParaRPr lang="en-US" sz="1800" dirty="0"/>
           </a:p>
           <a:p>
             <a:pPr marL="203200" indent="-203200">
@@ -15884,7 +15960,7 @@
               <a:buChar char="•"/>
             </a:pPr>
             <a:r>
-              <a:rPr lang="en-US" sz="1600" dirty="0">
+              <a:rPr lang="en-US" sz="1800" dirty="0">
                 <a:solidFill>
                   <a:srgbClr val="1B1F2A"/>
                 </a:solidFill>
@@ -15894,7 +15970,7 @@
               </a:rPr>
               <a:t>17,284 context rows</a:t>
             </a:r>
-            <a:endParaRPr lang="en-US" sz="1600" dirty="0"/>
+            <a:endParaRPr lang="en-US" sz="1800" dirty="0"/>
           </a:p>
         </p:txBody>
       </p:sp>
@@ -16012,11 +16088,11 @@
         <p:spPr>
           <a:xfrm>
             <a:off x="8046720" y="2834640"/>
-            <a:ext cx="3474720" cy="2926080"/>
+            <a:ext cx="3474720" cy="3017520"/>
           </a:xfrm>
           <a:prstGeom prst="roundRect">
             <a:avLst>
-              <a:gd name="adj" fmla="val 2500"/>
+              <a:gd name="adj" fmla="val 2424"/>
             </a:avLst>
           </a:prstGeom>
           <a:solidFill>
@@ -16038,8 +16114,8 @@
         </p:nvSpPr>
         <p:spPr>
           <a:xfrm>
-            <a:off x="8321040" y="3063240"/>
-            <a:ext cx="2926080" cy="2560320"/>
+            <a:off x="8321040" y="3108960"/>
+            <a:ext cx="2926080" cy="2651760"/>
           </a:xfrm>
           <a:prstGeom prst="rect">
             <a:avLst/>
@@ -16059,7 +16135,7 @@
               <a:buChar char="•"/>
             </a:pPr>
             <a:r>
-              <a:rPr lang="en-US" sz="1600" dirty="0">
+              <a:rPr lang="en-US" sz="1800" dirty="0">
                 <a:solidFill>
                   <a:srgbClr val="1B1F2A"/>
                 </a:solidFill>
@@ -16069,7 +16145,7 @@
               </a:rPr>
               <a:t>No training, no tuning</a:t>
             </a:r>
-            <a:endParaRPr lang="en-US" sz="1600" dirty="0"/>
+            <a:endParaRPr lang="en-US" sz="1800" dirty="0"/>
           </a:p>
           <a:p>
             <a:pPr marL="203200" indent="-203200">
@@ -16080,7 +16156,7 @@
               <a:buChar char="•"/>
             </a:pPr>
             <a:r>
-              <a:rPr lang="en-US" sz="1600" dirty="0">
+              <a:rPr lang="en-US" sz="1800" dirty="0">
                 <a:solidFill>
                   <a:srgbClr val="1B1F2A"/>
                 </a:solidFill>
@@ -16090,7 +16166,7 @@
               </a:rPr>
               <a:t>Single ensemble member</a:t>
             </a:r>
-            <a:endParaRPr lang="en-US" sz="1600" dirty="0"/>
+            <a:endParaRPr lang="en-US" sz="1800" dirty="0"/>
           </a:p>
           <a:p>
             <a:pPr marL="203200" indent="-203200">
@@ -16101,7 +16177,7 @@
               <a:buChar char="•"/>
             </a:pPr>
             <a:r>
-              <a:rPr lang="en-US" sz="1600" dirty="0">
+              <a:rPr lang="en-US" sz="1800" dirty="0">
                 <a:solidFill>
                   <a:srgbClr val="1B1F2A"/>
                 </a:solidFill>
@@ -16111,7 +16187,7 @@
               </a:rPr>
               <a:t>Slow at large context</a:t>
             </a:r>
-            <a:endParaRPr lang="en-US" sz="1600" dirty="0"/>
+            <a:endParaRPr lang="en-US" sz="1800" dirty="0"/>
           </a:p>
           <a:p>
             <a:pPr marL="203200" indent="-203200">
@@ -16122,7 +16198,7 @@
               <a:buChar char="•"/>
             </a:pPr>
             <a:r>
-              <a:rPr lang="en-US" sz="1600" dirty="0">
+              <a:rPr lang="en-US" sz="1800" dirty="0">
                 <a:solidFill>
                   <a:srgbClr val="1B1F2A"/>
                 </a:solidFill>
@@ -16132,7 +16208,7 @@
               </a:rPr>
               <a:t>500 context rows</a:t>
             </a:r>
-            <a:endParaRPr lang="en-US" sz="1600" dirty="0"/>
+            <a:endParaRPr lang="en-US" sz="1800" dirty="0"/>
           </a:p>
         </p:txBody>
       </p:sp>

</xml_diff>